<commit_message>
private markets modelling, cash-flow modelling, commitments pacing
</commit_message>
<xml_diff>
--- a/epsilon-phi-core/src/python/epsilonPhi/ep_saa/marketing/Auto.pptx
+++ b/epsilon-phi-core/src/python/epsilonPhi/ep_saa/marketing/Auto.pptx
@@ -132,6 +132,11 @@
     <p:ext uri="{EFAFB233-063F-42B5-8137-9DF3F51BA10A}">
       <p15:sldGuideLst xmlns:p15="http://schemas.microsoft.com/office/powerpoint/2012/main">
         <p15:guide id="1" orient="horz" pos="2160" userDrawn="1">
+          <p15:clr>
+            <a:srgbClr val="A4A3A4"/>
+          </p15:clr>
+        </p15:guide>
+        <p15:guide id="2" pos="2880">
           <p15:clr>
             <a:srgbClr val="A4A3A4"/>
           </p15:clr>
@@ -483,7 +488,7 @@
         </c:scaling>
         <c:delete val="1"/>
         <c:axPos val="b"/>
-        <c:numFmt formatCode="General" sourceLinked="1"/>
+        <c:numFmt formatCode="0.00%" sourceLinked="1"/>
         <c:majorTickMark val="none"/>
         <c:minorTickMark val="none"/>
         <c:tickLblPos val="nextTo"/>
@@ -9126,7 +9131,7 @@
                   <a:bodyPr/>
                   <a:lstStyle/>
                   <a:p>
-                    <a:fld id="{A57EDDFA-93A9-3E46-AAFD-2D8B810DAD34}" type="CELLRANGE">
+                    <a:fld id="{E57F410E-030C-B84C-9EA3-7A2607E8008F}" type="CELLRANGE">
                       <a:rPr lang="en-US"/>
                       <a:pPr/>
                       <a:t>[CELLRANGE]</a:t>
@@ -9164,7 +9169,7 @@
                   <a:bodyPr/>
                   <a:lstStyle/>
                   <a:p>
-                    <a:fld id="{C5133F55-6787-5B44-9767-8231E5B07E8C}" type="CELLRANGE">
+                    <a:fld id="{D7EB1CD3-7B38-344F-B3BC-ADC396F71747}" type="CELLRANGE">
                       <a:rPr lang="en-US"/>
                       <a:pPr/>
                       <a:t>[CELLRANGE]</a:t>
@@ -9217,7 +9222,7 @@
                         <a:cs typeface="+mn-cs"/>
                       </a:defRPr>
                     </a:pPr>
-                    <a:fld id="{78554C57-2753-AF47-82D0-B212E27C16C4}" type="CELLRANGE">
+                    <a:fld id="{65DB1FB6-F713-EF4E-AD1E-2917CEEF8DBD}" type="CELLRANGE">
                       <a:rPr lang="en-US"/>
                       <a:pPr>
                         <a:defRPr/>
@@ -9751,7 +9756,7 @@
                   <a:bodyPr/>
                   <a:lstStyle/>
                   <a:p>
-                    <a:fld id="{EB0B8B92-9FFB-3F4D-8998-541F762FDF2E}" type="CELLRANGE">
+                    <a:fld id="{EECE791D-7BC4-8142-BF92-BCBD5DF532DE}" type="CELLRANGE">
                       <a:rPr lang="en-US"/>
                       <a:pPr/>
                       <a:t>[CELLRANGE]</a:t>
@@ -9789,7 +9794,7 @@
                   <a:bodyPr/>
                   <a:lstStyle/>
                   <a:p>
-                    <a:fld id="{4570AFF3-425A-934C-8717-DACEE978E8ED}" type="CELLRANGE">
+                    <a:fld id="{D2884F45-A16D-1D49-8169-CC06CC58AA31}" type="CELLRANGE">
                       <a:rPr lang="en-US"/>
                       <a:pPr/>
                       <a:t>[CELLRANGE]</a:t>
@@ -10272,7 +10277,7 @@
                   <a:bodyPr/>
                   <a:lstStyle/>
                   <a:p>
-                    <a:fld id="{716E7BB9-905C-A940-B6AA-363E39BF0960}" type="CELLRANGE">
+                    <a:fld id="{A3952062-DB02-2547-8BD0-8B1ECCFAAE9F}" type="CELLRANGE">
                       <a:rPr lang="en-US"/>
                       <a:pPr/>
                       <a:t>[CELLRANGE]</a:t>
@@ -10310,7 +10315,7 @@
                   <a:bodyPr/>
                   <a:lstStyle/>
                   <a:p>
-                    <a:fld id="{CFC47FD2-4FFB-8F47-AE11-8B9F5F286B82}" type="CELLRANGE">
+                    <a:fld id="{18592CAF-7405-754A-A3A5-9E62E7D8C054}" type="CELLRANGE">
                       <a:rPr lang="en-US"/>
                       <a:pPr/>
                       <a:t>[CELLRANGE]</a:t>
@@ -10354,7 +10359,7 @@
                   <a:bodyPr/>
                   <a:lstStyle/>
                   <a:p>
-                    <a:fld id="{07688981-5A1C-6049-9F29-8DE644B694A2}" type="CELLRANGE">
+                    <a:fld id="{930241F2-1F78-2540-8236-4005A7F2301A}" type="CELLRANGE">
                       <a:rPr lang="en-US"/>
                       <a:pPr/>
                       <a:t>[CELLRANGE]</a:t>
@@ -10392,7 +10397,7 @@
                   <a:bodyPr/>
                   <a:lstStyle/>
                   <a:p>
-                    <a:fld id="{4104538A-3E26-C649-91D4-1F4E3B5B84FF}" type="CELLRANGE">
+                    <a:fld id="{1E0AB4D6-1B3C-2F42-8FA4-04EBFC621841}" type="CELLRANGE">
                       <a:rPr lang="en-US"/>
                       <a:pPr/>
                       <a:t>[CELLRANGE]</a:t>
@@ -10424,7 +10429,7 @@
                   <a:bodyPr/>
                   <a:lstStyle/>
                   <a:p>
-                    <a:fld id="{8BF12B1C-892A-9A43-A371-29098E3D8B64}" type="CELLRANGE">
+                    <a:fld id="{440358A2-A3CE-E641-B418-0D1DE6FCE8E3}" type="CELLRANGE">
                       <a:rPr lang="en-US"/>
                       <a:pPr/>
                       <a:t>[CELLRANGE]</a:t>
@@ -10457,7 +10462,7 @@
                   <a:bodyPr/>
                   <a:lstStyle/>
                   <a:p>
-                    <a:fld id="{048D4229-2FC8-1B47-9969-D436E6FA231C}" type="CELLRANGE">
+                    <a:fld id="{22F9657F-2BB1-B543-966E-B85C4CD6C411}" type="CELLRANGE">
                       <a:rPr lang="en-US"/>
                       <a:pPr/>
                       <a:t>[CELLRANGE]</a:t>
@@ -10490,7 +10495,7 @@
                   <a:bodyPr/>
                   <a:lstStyle/>
                   <a:p>
-                    <a:fld id="{D76ED385-FFD0-954E-B25A-C1CCDE55DCF6}" type="CELLRANGE">
+                    <a:fld id="{63D19133-341A-5C4A-9C0A-E16CAA7E4E1B}" type="CELLRANGE">
                       <a:rPr lang="en-US"/>
                       <a:pPr/>
                       <a:t>[CELLRANGE]</a:t>
@@ -11468,7 +11473,7 @@
                   <a:bodyPr/>
                   <a:lstStyle/>
                   <a:p>
-                    <a:fld id="{A56547F3-CB6C-FF43-A295-4270E8CA7CFE}" type="CELLRANGE">
+                    <a:fld id="{164B7A71-085E-2744-97C4-300C691E50D7}" type="CELLRANGE">
                       <a:rPr lang="en-US"/>
                       <a:pPr/>
                       <a:t>[CELLRANGE]</a:t>
@@ -11500,7 +11505,7 @@
                   <a:bodyPr/>
                   <a:lstStyle/>
                   <a:p>
-                    <a:fld id="{2E24BCA5-D219-A540-A5EE-2648FC2DD606}" type="CELLRANGE">
+                    <a:fld id="{15F7738E-0EDE-584C-8A56-346A7D4D6344}" type="CELLRANGE">
                       <a:rPr lang="en-US"/>
                       <a:pPr/>
                       <a:t>[CELLRANGE]</a:t>
@@ -11539,7 +11544,7 @@
                   <a:bodyPr/>
                   <a:lstStyle/>
                   <a:p>
-                    <a:fld id="{57A7F2A5-CE9D-A74D-B561-1384FA250286}" type="CELLRANGE">
+                    <a:fld id="{9DEFB410-9568-F344-B64F-D2610DC4D843}" type="CELLRANGE">
                       <a:rPr lang="en-US"/>
                       <a:pPr/>
                       <a:t>[CELLRANGE]</a:t>
@@ -11604,7 +11609,7 @@
                   <a:bodyPr/>
                   <a:lstStyle/>
                   <a:p>
-                    <a:fld id="{6ED0DBD9-0AFE-3649-9E09-3B76CF771C6D}" type="CELLRANGE">
+                    <a:fld id="{DBA676E2-FAE2-CB46-8208-AB521526A02C}" type="CELLRANGE">
                       <a:rPr lang="en-US"/>
                       <a:pPr/>
                       <a:t>[CELLRANGE]</a:t>
@@ -11642,7 +11647,7 @@
                   <a:bodyPr/>
                   <a:lstStyle/>
                   <a:p>
-                    <a:fld id="{2911E635-A281-6943-A32A-49E271007C61}" type="CELLRANGE">
+                    <a:fld id="{39631E66-A3EA-0346-B960-8C8621BE56FB}" type="CELLRANGE">
                       <a:rPr lang="en-US"/>
                       <a:pPr/>
                       <a:t>[CELLRANGE]</a:t>
@@ -11680,7 +11685,7 @@
                   <a:bodyPr/>
                   <a:lstStyle/>
                   <a:p>
-                    <a:fld id="{610BAA7E-20AD-F641-BF70-10087011A3CD}" type="CELLRANGE">
+                    <a:fld id="{FD2D63ED-00D9-BF4F-96C3-22CF7CB19AC0}" type="CELLRANGE">
                       <a:rPr lang="en-US"/>
                       <a:pPr/>
                       <a:t>[CELLRANGE]</a:t>
@@ -11718,7 +11723,7 @@
                   <a:bodyPr/>
                   <a:lstStyle/>
                   <a:p>
-                    <a:fld id="{747EE2AB-F0B4-174B-9CDE-7F67FEF989D9}" type="CELLRANGE">
+                    <a:fld id="{B7F83FFD-9546-DF4D-A100-6220D073C137}" type="CELLRANGE">
                       <a:rPr lang="en-US"/>
                       <a:pPr/>
                       <a:t>[CELLRANGE]</a:t>
@@ -11756,7 +11761,7 @@
                   <a:bodyPr/>
                   <a:lstStyle/>
                   <a:p>
-                    <a:fld id="{B02FB482-3D12-114A-A993-41BB668568DC}" type="CELLRANGE">
+                    <a:fld id="{E2FFC867-0443-FA4A-8754-ECECBF2E4ABA}" type="CELLRANGE">
                       <a:rPr lang="en-US"/>
                       <a:pPr/>
                       <a:t>[CELLRANGE]</a:t>
@@ -11794,7 +11799,7 @@
                   <a:bodyPr/>
                   <a:lstStyle/>
                   <a:p>
-                    <a:fld id="{49FC2E90-18AB-4D46-B22B-ED56D2DEC58B}" type="CELLRANGE">
+                    <a:fld id="{BE080AA1-3828-C94F-AEE2-854699D9F7E5}" type="CELLRANGE">
                       <a:rPr lang="en-US"/>
                       <a:pPr/>
                       <a:t>[CELLRANGE]</a:t>
@@ -13561,7 +13566,7 @@
                   <a:bodyPr/>
                   <a:lstStyle/>
                   <a:p>
-                    <a:fld id="{D199EFFD-75BB-144D-B8F5-190479683594}" type="CELLRANGE">
+                    <a:fld id="{17D09FC1-D311-4E4D-8A37-5605FCFB34DD}" type="CELLRANGE">
                       <a:rPr lang="en-US"/>
                       <a:pPr/>
                       <a:t>[CELLRANGE]</a:t>
@@ -35221,7 +35226,7 @@
           <a:p>
             <a:fld id="{A41FBADA-4773-404F-874F-B3857A68950B}" type="datetimeFigureOut">
               <a:rPr lang="en-US" smtClean="0"/>
-              <a:t>7/3/25</a:t>
+              <a:t>7/4/25</a:t>
             </a:fld>
             <a:endParaRPr lang="en-US"/>
           </a:p>
@@ -35788,7 +35793,7 @@
           <a:p>
             <a:fld id="{7C39B213-3102-C349-9554-E434846F78E6}" type="datetime1">
               <a:rPr lang="en-GB" smtClean="0"/>
-              <a:t>03/07/2025</a:t>
+              <a:t>04/07/2025</a:t>
             </a:fld>
             <a:endParaRPr lang="en-US"/>
           </a:p>
@@ -35958,7 +35963,7 @@
           <a:p>
             <a:fld id="{932F3922-980F-3047-91E3-B20D946F972E}" type="datetime1">
               <a:rPr lang="en-GB" smtClean="0"/>
-              <a:t>03/07/2025</a:t>
+              <a:t>04/07/2025</a:t>
             </a:fld>
             <a:endParaRPr lang="en-US"/>
           </a:p>
@@ -36138,7 +36143,7 @@
           <a:p>
             <a:fld id="{EA2351C3-CB6C-CB43-A403-149A332B98B6}" type="datetime1">
               <a:rPr lang="en-GB" smtClean="0"/>
-              <a:t>03/07/2025</a:t>
+              <a:t>04/07/2025</a:t>
             </a:fld>
             <a:endParaRPr lang="en-US"/>
           </a:p>
@@ -36308,7 +36313,7 @@
           <a:p>
             <a:fld id="{D8E61742-974A-4443-8BE3-693B2B3ED8AD}" type="datetime1">
               <a:rPr lang="en-GB" smtClean="0"/>
-              <a:t>03/07/2025</a:t>
+              <a:t>04/07/2025</a:t>
             </a:fld>
             <a:endParaRPr lang="en-US"/>
           </a:p>
@@ -36552,7 +36557,7 @@
           <a:p>
             <a:fld id="{2DFC1FB4-6600-964E-87AE-7944E8A54BF4}" type="datetime1">
               <a:rPr lang="en-GB" smtClean="0"/>
-              <a:t>03/07/2025</a:t>
+              <a:t>04/07/2025</a:t>
             </a:fld>
             <a:endParaRPr lang="en-US"/>
           </a:p>
@@ -36784,7 +36789,7 @@
           <a:p>
             <a:fld id="{2B71E02E-8688-0D40-8D95-F6B633E19384}" type="datetime1">
               <a:rPr lang="en-GB" smtClean="0"/>
-              <a:t>03/07/2025</a:t>
+              <a:t>04/07/2025</a:t>
             </a:fld>
             <a:endParaRPr lang="en-US"/>
           </a:p>
@@ -37151,7 +37156,7 @@
           <a:p>
             <a:fld id="{C3E2112C-A07D-0C49-83D0-97E7715572E8}" type="datetime1">
               <a:rPr lang="en-GB" smtClean="0"/>
-              <a:t>03/07/2025</a:t>
+              <a:t>04/07/2025</a:t>
             </a:fld>
             <a:endParaRPr lang="en-US"/>
           </a:p>
@@ -37269,7 +37274,7 @@
           <a:p>
             <a:fld id="{ACE3FB06-81A1-7145-AA10-23CB90609DB1}" type="datetime1">
               <a:rPr lang="en-GB" smtClean="0"/>
-              <a:t>03/07/2025</a:t>
+              <a:t>04/07/2025</a:t>
             </a:fld>
             <a:endParaRPr lang="en-US"/>
           </a:p>
@@ -37364,7 +37369,7 @@
           <a:p>
             <a:fld id="{7FA6BF7C-B1D2-D341-B6EA-0F9EDB8B80EA}" type="datetime1">
               <a:rPr lang="en-GB" smtClean="0"/>
-              <a:t>03/07/2025</a:t>
+              <a:t>04/07/2025</a:t>
             </a:fld>
             <a:endParaRPr lang="en-US"/>
           </a:p>
@@ -37641,7 +37646,7 @@
           <a:p>
             <a:fld id="{0CF0714D-A05F-CA49-830F-7B0ACED6C706}" type="datetime1">
               <a:rPr lang="en-GB" smtClean="0"/>
-              <a:t>03/07/2025</a:t>
+              <a:t>04/07/2025</a:t>
             </a:fld>
             <a:endParaRPr lang="en-US"/>
           </a:p>
@@ -37898,7 +37903,7 @@
           <a:p>
             <a:fld id="{1A7311A0-74F8-7840-9594-267945A9A042}" type="datetime1">
               <a:rPr lang="en-GB" smtClean="0"/>
-              <a:t>03/07/2025</a:t>
+              <a:t>04/07/2025</a:t>
             </a:fld>
             <a:endParaRPr lang="en-US"/>
           </a:p>
@@ -38111,7 +38116,7 @@
           <a:p>
             <a:fld id="{7B41A623-B36F-C440-9672-F52869BB3AE9}" type="datetime1">
               <a:rPr lang="en-GB" smtClean="0"/>
-              <a:t>03/07/2025</a:t>
+              <a:t>04/07/2025</a:t>
             </a:fld>
             <a:endParaRPr lang="en-US"/>
           </a:p>
@@ -39513,35 +39518,6 @@
       </p:sp>
       <p:sp>
         <p:nvSpPr>
-          <p:cNvPr id="7" name="Slide Number Placeholder 6">
-            <a:extLst>
-              <a:ext uri="{FF2B5EF4-FFF2-40B4-BE49-F238E27FC236}">
-                <a16:creationId xmlns:a16="http://schemas.microsoft.com/office/drawing/2014/main" id="{BA5CDC96-F6FD-9172-CCBD-9AD709D7C615}"/>
-              </a:ext>
-            </a:extLst>
-          </p:cNvPr>
-          <p:cNvSpPr>
-            <a:spLocks noGrp="1"/>
-          </p:cNvSpPr>
-          <p:nvPr>
-            <p:ph type="sldNum" sz="quarter" idx="12"/>
-          </p:nvPr>
-        </p:nvSpPr>
-        <p:spPr/>
-        <p:txBody>
-          <a:bodyPr/>
-          <a:lstStyle/>
-          <a:p>
-            <a:fld id="{3647A49E-DC7B-E44E-B81C-A7ED720E17C2}" type="slidenum">
-              <a:rPr lang="en-US" smtClean="0"/>
-              <a:t>13</a:t>
-            </a:fld>
-            <a:endParaRPr lang="en-US"/>
-          </a:p>
-        </p:txBody>
-      </p:sp>
-      <p:sp>
-        <p:nvSpPr>
           <p:cNvPr id="2" name="TextBox 1">
             <a:extLst>
               <a:ext uri="{FF2B5EF4-FFF2-40B4-BE49-F238E27FC236}">
@@ -39802,8 +39778,8 @@
         </p:nvSpPr>
         <p:spPr>
           <a:xfrm>
-            <a:off x="0" y="6646224"/>
-            <a:ext cx="9010662" cy="215444"/>
+            <a:off x="133338" y="6621448"/>
+            <a:ext cx="9010662" cy="200055"/>
           </a:xfrm>
           <a:prstGeom prst="rect">
             <a:avLst/>
@@ -39817,7 +39793,7 @@
           <a:lstStyle/>
           <a:p>
             <a:r>
-              <a:rPr lang="en-US" sz="800" dirty="0"/>
+              <a:rPr lang="en-US" sz="700" dirty="0"/>
               <a:t>Intel Stock is return is modelled using the stocks designated GICS sector, in this case, S&amp;P 500 Information Technology. The systematic sector risk is adjusted upwards to match the stocks historical trading volatility</a:t>
             </a:r>
           </a:p>
@@ -39893,35 +39869,6 @@
               </a:rPr>
               <a:t>Concentrated Equity Position Risk</a:t>
             </a:r>
-          </a:p>
-        </p:txBody>
-      </p:sp>
-      <p:sp>
-        <p:nvSpPr>
-          <p:cNvPr id="7" name="Slide Number Placeholder 6">
-            <a:extLst>
-              <a:ext uri="{FF2B5EF4-FFF2-40B4-BE49-F238E27FC236}">
-                <a16:creationId xmlns:a16="http://schemas.microsoft.com/office/drawing/2014/main" id="{847F2D7A-83F3-223D-8BBA-89BD7DFE4457}"/>
-              </a:ext>
-            </a:extLst>
-          </p:cNvPr>
-          <p:cNvSpPr>
-            <a:spLocks noGrp="1"/>
-          </p:cNvSpPr>
-          <p:nvPr>
-            <p:ph type="sldNum" sz="quarter" idx="12"/>
-          </p:nvPr>
-        </p:nvSpPr>
-        <p:spPr/>
-        <p:txBody>
-          <a:bodyPr/>
-          <a:lstStyle/>
-          <a:p>
-            <a:fld id="{3647A49E-DC7B-E44E-B81C-A7ED720E17C2}" type="slidenum">
-              <a:rPr lang="en-US" smtClean="0"/>
-              <a:t>14</a:t>
-            </a:fld>
-            <a:endParaRPr lang="en-US"/>
           </a:p>
         </p:txBody>
       </p:sp>
@@ -40380,35 +40327,6 @@
       </p:sp>
       <p:sp>
         <p:nvSpPr>
-          <p:cNvPr id="7" name="Slide Number Placeholder 6">
-            <a:extLst>
-              <a:ext uri="{FF2B5EF4-FFF2-40B4-BE49-F238E27FC236}">
-                <a16:creationId xmlns:a16="http://schemas.microsoft.com/office/drawing/2014/main" id="{55590E6E-AB34-363D-56C9-5148B5C31D87}"/>
-              </a:ext>
-            </a:extLst>
-          </p:cNvPr>
-          <p:cNvSpPr>
-            <a:spLocks noGrp="1"/>
-          </p:cNvSpPr>
-          <p:nvPr>
-            <p:ph type="sldNum" sz="quarter" idx="12"/>
-          </p:nvPr>
-        </p:nvSpPr>
-        <p:spPr/>
-        <p:txBody>
-          <a:bodyPr/>
-          <a:lstStyle/>
-          <a:p>
-            <a:fld id="{3647A49E-DC7B-E44E-B81C-A7ED720E17C2}" type="slidenum">
-              <a:rPr lang="en-US" smtClean="0"/>
-              <a:t>15</a:t>
-            </a:fld>
-            <a:endParaRPr lang="en-US"/>
-          </a:p>
-        </p:txBody>
-      </p:sp>
-      <p:sp>
-        <p:nvSpPr>
           <p:cNvPr id="2" name="TextBox 1">
             <a:extLst>
               <a:ext uri="{FF2B5EF4-FFF2-40B4-BE49-F238E27FC236}">
@@ -40779,35 +40697,6 @@
               </a:rPr>
               <a:t>Example Staged Diversification</a:t>
             </a:r>
-          </a:p>
-        </p:txBody>
-      </p:sp>
-      <p:sp>
-        <p:nvSpPr>
-          <p:cNvPr id="7" name="Slide Number Placeholder 6">
-            <a:extLst>
-              <a:ext uri="{FF2B5EF4-FFF2-40B4-BE49-F238E27FC236}">
-                <a16:creationId xmlns:a16="http://schemas.microsoft.com/office/drawing/2014/main" id="{BBE58329-9F3C-614A-2C87-510AE8E8013D}"/>
-              </a:ext>
-            </a:extLst>
-          </p:cNvPr>
-          <p:cNvSpPr>
-            <a:spLocks noGrp="1"/>
-          </p:cNvSpPr>
-          <p:nvPr>
-            <p:ph type="sldNum" sz="quarter" idx="12"/>
-          </p:nvPr>
-        </p:nvSpPr>
-        <p:spPr/>
-        <p:txBody>
-          <a:bodyPr/>
-          <a:lstStyle/>
-          <a:p>
-            <a:fld id="{3647A49E-DC7B-E44E-B81C-A7ED720E17C2}" type="slidenum">
-              <a:rPr lang="en-US" smtClean="0"/>
-              <a:t>16</a:t>
-            </a:fld>
-            <a:endParaRPr lang="en-US"/>
           </a:p>
         </p:txBody>
       </p:sp>
@@ -41237,35 +41126,6 @@
       </p:grpSpPr>
       <p:sp>
         <p:nvSpPr>
-          <p:cNvPr id="7" name="Slide Number Placeholder 6">
-            <a:extLst>
-              <a:ext uri="{FF2B5EF4-FFF2-40B4-BE49-F238E27FC236}">
-                <a16:creationId xmlns:a16="http://schemas.microsoft.com/office/drawing/2014/main" id="{7B9821BD-67DD-3DCD-7419-158E236EF22C}"/>
-              </a:ext>
-            </a:extLst>
-          </p:cNvPr>
-          <p:cNvSpPr>
-            <a:spLocks noGrp="1"/>
-          </p:cNvSpPr>
-          <p:nvPr>
-            <p:ph type="sldNum" sz="quarter" idx="12"/>
-          </p:nvPr>
-        </p:nvSpPr>
-        <p:spPr/>
-        <p:txBody>
-          <a:bodyPr/>
-          <a:lstStyle/>
-          <a:p>
-            <a:fld id="{3647A49E-DC7B-E44E-B81C-A7ED720E17C2}" type="slidenum">
-              <a:rPr lang="en-US" smtClean="0"/>
-              <a:t>17</a:t>
-            </a:fld>
-            <a:endParaRPr lang="en-US"/>
-          </a:p>
-        </p:txBody>
-      </p:sp>
-      <p:sp>
-        <p:nvSpPr>
           <p:cNvPr id="2" name="TextBox 1">
             <a:extLst>
               <a:ext uri="{FF2B5EF4-FFF2-40B4-BE49-F238E27FC236}">
@@ -41595,35 +41455,6 @@
           <a:lstStyle/>
           <a:p>
             <a:pPr algn="ctr"/>
-            <a:endParaRPr lang="en-US"/>
-          </a:p>
-        </p:txBody>
-      </p:sp>
-      <p:sp>
-        <p:nvSpPr>
-          <p:cNvPr id="7" name="Slide Number Placeholder 6">
-            <a:extLst>
-              <a:ext uri="{FF2B5EF4-FFF2-40B4-BE49-F238E27FC236}">
-                <a16:creationId xmlns:a16="http://schemas.microsoft.com/office/drawing/2014/main" id="{72803CAA-76E4-E929-7F38-A5727D9EA43F}"/>
-              </a:ext>
-            </a:extLst>
-          </p:cNvPr>
-          <p:cNvSpPr>
-            <a:spLocks noGrp="1"/>
-          </p:cNvSpPr>
-          <p:nvPr>
-            <p:ph type="sldNum" sz="quarter" idx="12"/>
-          </p:nvPr>
-        </p:nvSpPr>
-        <p:spPr/>
-        <p:txBody>
-          <a:bodyPr/>
-          <a:lstStyle/>
-          <a:p>
-            <a:fld id="{3647A49E-DC7B-E44E-B81C-A7ED720E17C2}" type="slidenum">
-              <a:rPr lang="en-US" smtClean="0"/>
-              <a:t>18</a:t>
-            </a:fld>
             <a:endParaRPr lang="en-US"/>
           </a:p>
         </p:txBody>
@@ -44018,35 +43849,6 @@
               </a:rPr>
               <a:t>Modelling Structured Notes</a:t>
             </a:r>
-          </a:p>
-        </p:txBody>
-      </p:sp>
-      <p:sp>
-        <p:nvSpPr>
-          <p:cNvPr id="7" name="Slide Number Placeholder 6">
-            <a:extLst>
-              <a:ext uri="{FF2B5EF4-FFF2-40B4-BE49-F238E27FC236}">
-                <a16:creationId xmlns:a16="http://schemas.microsoft.com/office/drawing/2014/main" id="{4D5CED23-1625-EEDF-CB56-65CE104CFA6B}"/>
-              </a:ext>
-            </a:extLst>
-          </p:cNvPr>
-          <p:cNvSpPr>
-            <a:spLocks noGrp="1"/>
-          </p:cNvSpPr>
-          <p:nvPr>
-            <p:ph type="sldNum" sz="quarter" idx="12"/>
-          </p:nvPr>
-        </p:nvSpPr>
-        <p:spPr/>
-        <p:txBody>
-          <a:bodyPr/>
-          <a:lstStyle/>
-          <a:p>
-            <a:fld id="{3647A49E-DC7B-E44E-B81C-A7ED720E17C2}" type="slidenum">
-              <a:rPr lang="en-US" smtClean="0"/>
-              <a:t>20</a:t>
-            </a:fld>
-            <a:endParaRPr lang="en-US" dirty="0"/>
           </a:p>
         </p:txBody>
       </p:sp>

</xml_diff>